<commit_message>
Guide: past seasons, team banners, fixes after locking, QR poster, SOLD celebration, humour, offline pack
Six new slides and updated ones (roles: who is an admin; AI fallback;
auction-day checklist). Screenshots use made-up sample data only.

Co-Authored-By: Claude Opus 5.5 <noreply@anthropic.com>
Claude-Session: https://claude.ai/code/session_018eFxbAXi71u5eBxhq19fjA
</commit_message>
<xml_diff>
--- a/docs/guide/AuctionXI-Guide.pptx
+++ b/docs/guide/AuctionXI-Guide.pptx
@@ -30,9 +30,15 @@
     <p:sldId id="278" r:id="rId24"/>
     <p:sldId id="279" r:id="rId25"/>
     <p:sldId id="280" r:id="rId26"/>
+    <p:sldId id="281" r:id="rId27"/>
+    <p:sldId id="282" r:id="rId28"/>
+    <p:sldId id="283" r:id="rId29"/>
+    <p:sldId id="284" r:id="rId30"/>
+    <p:sldId id="285" r:id="rId31"/>
+    <p:sldId id="286" r:id="rId32"/>
   </p:sldIdLst>
   <p:notesMasterIdLst>
-    <p:notesMasterId r:id="rId27"/>
+    <p:notesMasterId r:id="rId33"/>
   </p:notesMasterIdLst>
   <p:sldSz cx="12192000" cy="6858000"/>
   <p:notesSz cx="6858000" cy="12192000"/>
@@ -617,13 +623,390 @@
           <a:p>
             <a:r>
               <a:rPr lang="en-US" dirty="0"/>
-              <a:t>A7 · AI assistant (optional)
+              <a:t>A7 · Players
+Upload, check, choose each player's list, then lock
+Players → Upload the players CSV. Fix anything flagged, or edit in the table.
+List column for each player: Auction, Waiting list or Registration cancelled. Works even after locking (except for the player up for bidding).
+Player photos: one at a time, or many at once named by player number or full name.
+Lock the list when it is final.
+Waiting-list players come in only if you move them to Auction. Cancelled players stay on record but are left out of the auction, lists and downloads.</a:t>
+            </a:r>
+            <a:endParaRPr lang="en-US" dirty="0"/>
+          </a:p>
+        </p:txBody>
+      </p:sp>
+      <p:sp>
+        <p:nvSpPr>
+          <p:cNvPr id="4" name="Slide Number Placeholder 3"/>
+          <p:cNvSpPr>
+            <a:spLocks noGrp="1"/>
+          </p:cNvSpPr>
+          <p:nvPr>
+            <p:ph type="sldNum" sz="quarter" idx="10"/>
+          </p:nvPr>
+        </p:nvSpPr>
+        <p:spPr/>
+        <p:txBody>
+          <a:bodyPr/>
+          <a:lstStyle/>
+          <a:p>
+            <a:fld id="{F7021451-1387-4CA6-816F-3879F97B5CBC}" type="slidenum">
+              <a:rPr lang="en-US"/>
+              <a:t>10</a:t>
+            </a:fld>
+            <a:endParaRPr lang="en-US"/>
+          </a:p>
+        </p:txBody>
+      </p:sp>
+    </p:spTree>
+    <p:extLst>
+      <p:ext uri="{BB962C8B-B14F-4D97-AF65-F5344CB8AC3E}">
+        <p14:creationId xmlns:p14="http://schemas.microsoft.com/office/powerpoint/2010/main" val="1024086991"/>
+      </p:ext>
+    </p:extLst>
+  </p:cSld>
+  <p:clrMapOvr>
+    <a:masterClrMapping/>
+  </p:clrMapOvr>
+</p:notes>
+</file>
+
+<file path=ppt/notesSlides/notesSlide11.xml><?xml version="1.0" encoding="utf-8"?>
+<p:notes xmlns:a="http://schemas.openxmlformats.org/drawingml/2006/main" xmlns:r="http://schemas.openxmlformats.org/officeDocument/2006/relationships" xmlns:p="http://schemas.openxmlformats.org/presentationml/2006/main">
+  <p:cSld>
+    <p:spTree>
+      <p:nvGrpSpPr>
+        <p:cNvPr id="1" name=""/>
+        <p:cNvGrpSpPr/>
+        <p:nvPr/>
+      </p:nvGrpSpPr>
+      <p:grpSpPr>
+        <a:xfrm>
+          <a:off x="0" y="0"/>
+          <a:ext cx="0" cy="0"/>
+          <a:chOff x="0" y="0"/>
+          <a:chExt cx="0" cy="0"/>
+        </a:xfrm>
+      </p:grpSpPr>
+      <p:sp>
+        <p:nvSpPr>
+          <p:cNvPr id="2" name="Slide Image Placeholder 1"/>
+          <p:cNvSpPr>
+            <a:spLocks noGrp="1" noRot="1" noChangeAspect="1"/>
+          </p:cNvSpPr>
+          <p:nvPr>
+            <p:ph type="sldImg"/>
+          </p:nvPr>
+        </p:nvSpPr>
+        <p:spPr/>
+      </p:sp>
+      <p:sp>
+        <p:nvSpPr>
+          <p:cNvPr id="3" name="Notes Placeholder 2"/>
+          <p:cNvSpPr>
+            <a:spLocks noGrp="1"/>
+          </p:cNvSpPr>
+          <p:nvPr>
+            <p:ph type="body" idx="1"/>
+          </p:nvPr>
+        </p:nvSpPr>
+        <p:spPr/>
+        <p:txBody>
+          <a:bodyPr/>
+          <a:lstStyle/>
+          <a:p>
+            <a:r>
+              <a:rPr lang="en-US" dirty="0"/>
+              <a:t>A8 · Lock, and small fixes after it
+Locking fixes the list, not the spelling
+After locking
+Fixed · Who is in the auction, pools, base prices, captains
+Still editable · Edit: name, role, stats, notes. Also the list and photos
+Every change saves at once and says so (✓ saved). Unlock any time before the start; starting locks it for good.</a:t>
+            </a:r>
+            <a:endParaRPr lang="en-US" dirty="0"/>
+          </a:p>
+        </p:txBody>
+      </p:sp>
+      <p:sp>
+        <p:nvSpPr>
+          <p:cNvPr id="4" name="Slide Number Placeholder 3"/>
+          <p:cNvSpPr>
+            <a:spLocks noGrp="1"/>
+          </p:cNvSpPr>
+          <p:nvPr>
+            <p:ph type="sldNum" sz="quarter" idx="10"/>
+          </p:nvPr>
+        </p:nvSpPr>
+        <p:spPr/>
+        <p:txBody>
+          <a:bodyPr/>
+          <a:lstStyle/>
+          <a:p>
+            <a:fld id="{F7021451-1387-4CA6-816F-3879F97B5CBC}" type="slidenum">
+              <a:rPr lang="en-US"/>
+              <a:t>11</a:t>
+            </a:fld>
+            <a:endParaRPr lang="en-US"/>
+          </a:p>
+        </p:txBody>
+      </p:sp>
+    </p:spTree>
+    <p:extLst>
+      <p:ext uri="{BB962C8B-B14F-4D97-AF65-F5344CB8AC3E}">
+        <p14:creationId xmlns:p14="http://schemas.microsoft.com/office/powerpoint/2010/main" val="1024086991"/>
+      </p:ext>
+    </p:extLst>
+  </p:cSld>
+  <p:clrMapOvr>
+    <a:masterClrMapping/>
+  </p:clrMapOvr>
+</p:notes>
+</file>
+
+<file path=ppt/notesSlides/notesSlide12.xml><?xml version="1.0" encoding="utf-8"?>
+<p:notes xmlns:a="http://schemas.openxmlformats.org/drawingml/2006/main" xmlns:r="http://schemas.openxmlformats.org/officeDocument/2006/relationships" xmlns:p="http://schemas.openxmlformats.org/presentationml/2006/main">
+  <p:cSld>
+    <p:spTree>
+      <p:nvGrpSpPr>
+        <p:cNvPr id="1" name=""/>
+        <p:cNvGrpSpPr/>
+        <p:nvPr/>
+      </p:nvGrpSpPr>
+      <p:grpSpPr>
+        <a:xfrm>
+          <a:off x="0" y="0"/>
+          <a:ext cx="0" cy="0"/>
+          <a:chOff x="0" y="0"/>
+          <a:chExt cx="0" cy="0"/>
+        </a:xfrm>
+      </p:grpSpPr>
+      <p:sp>
+        <p:nvSpPr>
+          <p:cNvPr id="2" name="Slide Image Placeholder 1"/>
+          <p:cNvSpPr>
+            <a:spLocks noGrp="1" noRot="1" noChangeAspect="1"/>
+          </p:cNvSpPr>
+          <p:nvPr>
+            <p:ph type="sldImg"/>
+          </p:nvPr>
+        </p:nvSpPr>
+        <p:spPr/>
+      </p:sp>
+      <p:sp>
+        <p:nvSpPr>
+          <p:cNvPr id="3" name="Notes Placeholder 2"/>
+          <p:cNvSpPr>
+            <a:spLocks noGrp="1"/>
+          </p:cNvSpPr>
+          <p:nvPr>
+            <p:ph type="body" idx="1"/>
+          </p:nvPr>
+        </p:nvSpPr>
+        <p:spPr/>
+        <p:txBody>
+          <a:bodyPr/>
+          <a:lstStyle/>
+          <a:p>
+            <a:r>
+              <a:rPr lang="en-US" dirty="0"/>
+              <a:t>A9 · Access and sharing
+Private while you set up, then share it
+Who can see · Meaning
+Private · Only admins. Use it while setting up.
+Link or code · Anyone with the link, QR or auction code.
+Listed · Also shown on the home page.
+Send each captain (and vice-captain) their own code, privately.
+Admin code lets a co-admin run the control room on another laptop.
+Present on Zoom or Meet: open the stage link and share that tab.</a:t>
+            </a:r>
+            <a:endParaRPr lang="en-US" dirty="0"/>
+          </a:p>
+        </p:txBody>
+      </p:sp>
+      <p:sp>
+        <p:nvSpPr>
+          <p:cNvPr id="4" name="Slide Number Placeholder 3"/>
+          <p:cNvSpPr>
+            <a:spLocks noGrp="1"/>
+          </p:cNvSpPr>
+          <p:nvPr>
+            <p:ph type="sldNum" sz="quarter" idx="10"/>
+          </p:nvPr>
+        </p:nvSpPr>
+        <p:spPr/>
+        <p:txBody>
+          <a:bodyPr/>
+          <a:lstStyle/>
+          <a:p>
+            <a:fld id="{F7021451-1387-4CA6-816F-3879F97B5CBC}" type="slidenum">
+              <a:rPr lang="en-US"/>
+              <a:t>12</a:t>
+            </a:fld>
+            <a:endParaRPr lang="en-US"/>
+          </a:p>
+        </p:txBody>
+      </p:sp>
+    </p:spTree>
+    <p:extLst>
+      <p:ext uri="{BB962C8B-B14F-4D97-AF65-F5344CB8AC3E}">
+        <p14:creationId xmlns:p14="http://schemas.microsoft.com/office/powerpoint/2010/main" val="1024086991"/>
+      </p:ext>
+    </p:extLst>
+  </p:cSld>
+  <p:clrMapOvr>
+    <a:masterClrMapping/>
+  </p:clrMapOvr>
+</p:notes>
+</file>
+
+<file path=ppt/notesSlides/notesSlide13.xml><?xml version="1.0" encoding="utf-8"?>
+<p:notes xmlns:a="http://schemas.openxmlformats.org/drawingml/2006/main" xmlns:r="http://schemas.openxmlformats.org/officeDocument/2006/relationships" xmlns:p="http://schemas.openxmlformats.org/presentationml/2006/main">
+  <p:cSld>
+    <p:spTree>
+      <p:nvGrpSpPr>
+        <p:cNvPr id="1" name=""/>
+        <p:cNvGrpSpPr/>
+        <p:nvPr/>
+      </p:nvGrpSpPr>
+      <p:grpSpPr>
+        <a:xfrm>
+          <a:off x="0" y="0"/>
+          <a:ext cx="0" cy="0"/>
+          <a:chOff x="0" y="0"/>
+          <a:chExt cx="0" cy="0"/>
+        </a:xfrm>
+      </p:grpSpPr>
+      <p:sp>
+        <p:nvSpPr>
+          <p:cNvPr id="2" name="Slide Image Placeholder 1"/>
+          <p:cNvSpPr>
+            <a:spLocks noGrp="1" noRot="1" noChangeAspect="1"/>
+          </p:cNvSpPr>
+          <p:nvPr>
+            <p:ph type="sldImg"/>
+          </p:nvPr>
+        </p:nvSpPr>
+        <p:spPr/>
+      </p:sp>
+      <p:sp>
+        <p:nvSpPr>
+          <p:cNvPr id="3" name="Notes Placeholder 2"/>
+          <p:cNvSpPr>
+            <a:spLocks noGrp="1"/>
+          </p:cNvSpPr>
+          <p:nvPr>
+            <p:ph type="body" idx="1"/>
+          </p:nvPr>
+        </p:nvSpPr>
+        <p:spPr/>
+        <p:txBody>
+          <a:bodyPr/>
+          <a:lstStyle/>
+          <a:p>
+            <a:r>
+              <a:rPr lang="en-US" dirty="0"/>
+              <a:t>A10 · QR poster
+A poster for the club house, in one click
+Access and sharing → Print QR poster.
+A4 or A3; dark like the stage, or light to save ink.
+It uses your banner, logo, date, venue, teams and auction code, and a big QR code that opens the auction.
+Print at 100% with no margins, or save as PDF and send it on WhatsApp.
+Pin one at the gate, one in the hall and one near the projector. The QR code is drawn on the laptop, so it works offline.</a:t>
+            </a:r>
+            <a:endParaRPr lang="en-US" dirty="0"/>
+          </a:p>
+        </p:txBody>
+      </p:sp>
+      <p:sp>
+        <p:nvSpPr>
+          <p:cNvPr id="4" name="Slide Number Placeholder 3"/>
+          <p:cNvSpPr>
+            <a:spLocks noGrp="1"/>
+          </p:cNvSpPr>
+          <p:nvPr>
+            <p:ph type="sldNum" sz="quarter" idx="10"/>
+          </p:nvPr>
+        </p:nvSpPr>
+        <p:spPr/>
+        <p:txBody>
+          <a:bodyPr/>
+          <a:lstStyle/>
+          <a:p>
+            <a:fld id="{F7021451-1387-4CA6-816F-3879F97B5CBC}" type="slidenum">
+              <a:rPr lang="en-US"/>
+              <a:t>13</a:t>
+            </a:fld>
+            <a:endParaRPr lang="en-US"/>
+          </a:p>
+        </p:txBody>
+      </p:sp>
+    </p:spTree>
+    <p:extLst>
+      <p:ext uri="{BB962C8B-B14F-4D97-AF65-F5344CB8AC3E}">
+        <p14:creationId xmlns:p14="http://schemas.microsoft.com/office/powerpoint/2010/main" val="1024086991"/>
+      </p:ext>
+    </p:extLst>
+  </p:cSld>
+  <p:clrMapOvr>
+    <a:masterClrMapping/>
+  </p:clrMapOvr>
+</p:notes>
+</file>
+
+<file path=ppt/notesSlides/notesSlide14.xml><?xml version="1.0" encoding="utf-8"?>
+<p:notes xmlns:a="http://schemas.openxmlformats.org/drawingml/2006/main" xmlns:r="http://schemas.openxmlformats.org/officeDocument/2006/relationships" xmlns:p="http://schemas.openxmlformats.org/presentationml/2006/main">
+  <p:cSld>
+    <p:spTree>
+      <p:nvGrpSpPr>
+        <p:cNvPr id="1" name=""/>
+        <p:cNvGrpSpPr/>
+        <p:nvPr/>
+      </p:nvGrpSpPr>
+      <p:grpSpPr>
+        <a:xfrm>
+          <a:off x="0" y="0"/>
+          <a:ext cx="0" cy="0"/>
+          <a:chOff x="0" y="0"/>
+          <a:chExt cx="0" cy="0"/>
+        </a:xfrm>
+      </p:grpSpPr>
+      <p:sp>
+        <p:nvSpPr>
+          <p:cNvPr id="2" name="Slide Image Placeholder 1"/>
+          <p:cNvSpPr>
+            <a:spLocks noGrp="1" noRot="1" noChangeAspect="1"/>
+          </p:cNvSpPr>
+          <p:nvPr>
+            <p:ph type="sldImg"/>
+          </p:nvPr>
+        </p:nvSpPr>
+        <p:spPr/>
+      </p:sp>
+      <p:sp>
+        <p:nvSpPr>
+          <p:cNvPr id="3" name="Notes Placeholder 2"/>
+          <p:cNvSpPr>
+            <a:spLocks noGrp="1"/>
+          </p:cNvSpPr>
+          <p:nvPr>
+            <p:ph type="body" idx="1"/>
+          </p:nvPr>
+        </p:nvSpPr>
+        <p:spPr/>
+        <p:txBody>
+          <a:bodyPr/>
+          <a:lstStyle/>
+          <a:p>
+            <a:r>
+              <a:rPr lang="en-US" dirty="0"/>
+              <a:t>A11 · AI assistant (optional)
 Use a free AI key for commentary and scouting notes
 Setup → AI assistant: choose Google Gemini (free key from AI Studio), Groq, OpenRouter, Claude or any compatible service.
 Paste your key and press Test. The key stays only in this browser: never in the database or on GitHub.
 AI commentary: tick it in the control room. If the AI is slow, the built-in line is used.
 Scouting notes: Players → AI button writes a note per player from the stats; you review before saving.
-Everything works without AI. It is only an extra.</a:t>
+If the key's limit runs out or the AI is down, every screen switches to the built-in commentary by itself, and AI comes back when it works again.</a:t>
             </a:r>
             <a:endParaRPr lang="en-US" dirty="0"/>
           </a:p>
@@ -646,7 +1029,7 @@
           <a:p>
             <a:fld id="{F7021451-1387-4CA6-816F-3879F97B5CBC}" type="slidenum">
               <a:rPr lang="en-US"/>
-              <a:t>10</a:t>
+              <a:t>14</a:t>
             </a:fld>
             <a:endParaRPr lang="en-US"/>
           </a:p>
@@ -665,7 +1048,7 @@
 </p:notes>
 </file>
 
-<file path=ppt/notesSlides/notesSlide11.xml><?xml version="1.0" encoding="utf-8"?>
+<file path=ppt/notesSlides/notesSlide15.xml><?xml version="1.0" encoding="utf-8"?>
 <p:notes xmlns:a="http://schemas.openxmlformats.org/drawingml/2006/main" xmlns:r="http://schemas.openxmlformats.org/officeDocument/2006/relationships" xmlns:p="http://schemas.openxmlformats.org/presentationml/2006/main">
   <p:cSld>
     <p:spTree>
@@ -711,7 +1094,7 @@
           <a:p>
             <a:r>
               <a:rPr lang="en-US" dirty="0"/>
-              <a:t>A8 · Rehearse
+              <a:t>A12 · Rehearse
 Run a mock auction first
 A mock is a practice copy with the same rules, teams, players and photos, and its own codes. Reset it or delete it when done; the real auction is untouched.
 Control room → Create mock auction.
@@ -741,7 +1124,7 @@
           <a:p>
             <a:fld id="{F7021451-1387-4CA6-816F-3879F97B5CBC}" type="slidenum">
               <a:rPr lang="en-US"/>
-              <a:t>11</a:t>
+              <a:t>15</a:t>
             </a:fld>
             <a:endParaRPr lang="en-US"/>
           </a:p>
@@ -760,7 +1143,7 @@
 </p:notes>
 </file>
 
-<file path=ppt/notesSlides/notesSlide12.xml><?xml version="1.0" encoding="utf-8"?>
+<file path=ppt/notesSlides/notesSlide16.xml><?xml version="1.0" encoding="utf-8"?>
 <p:notes xmlns:a="http://schemas.openxmlformats.org/drawingml/2006/main" xmlns:r="http://schemas.openxmlformats.org/officeDocument/2006/relationships" xmlns:p="http://schemas.openxmlformats.org/presentationml/2006/main">
   <p:cSld>
     <p:spTree>
@@ -806,10 +1189,10 @@
           <a:p>
             <a:r>
               <a:rPr lang="en-US" dirty="0"/>
-              <a:t>A9 · Control room
+              <a:t>A13 · Control room
 Run the auction from the laptop
 Start the auction: captains and vice-captains go into their teams.
-Next player: random draw (by pool or role), or a chit from the bowl (A10).
+Next player: random draw (by pool or role), or a chit from the bowl (A14).
 Bids come from phones, or click a team for a room bid.
 Mark sold or Unsold. Undo fixes mistakes.
 Key · Does
@@ -839,7 +1222,7 @@
           <a:p>
             <a:fld id="{F7021451-1387-4CA6-816F-3879F97B5CBC}" type="slidenum">
               <a:rPr lang="en-US"/>
-              <a:t>12</a:t>
+              <a:t>16</a:t>
             </a:fld>
             <a:endParaRPr lang="en-US"/>
           </a:p>
@@ -858,7 +1241,7 @@
 </p:notes>
 </file>
 
-<file path=ppt/notesSlides/notesSlide13.xml><?xml version="1.0" encoding="utf-8"?>
+<file path=ppt/notesSlides/notesSlide17.xml><?xml version="1.0" encoding="utf-8"?>
 <p:notes xmlns:a="http://schemas.openxmlformats.org/drawingml/2006/main" xmlns:r="http://schemas.openxmlformats.org/officeDocument/2006/relationships" xmlns:p="http://schemas.openxmlformats.org/presentationml/2006/main">
   <p:cSld>
     <p:spTree>
@@ -904,7 +1287,7 @@
           <a:p>
             <a:r>
               <a:rPr lang="en-US" dirty="0"/>
-              <a:t>A10 · Find any player
+              <a:t>A14 · Find any player
 Search by name, by number, or both
 Next player → Chit: type what is on the chit and press Enter to bring them up.
 On the stage: show a player's profile on the big screen.
@@ -935,7 +1318,7 @@
           <a:p>
             <a:fld id="{F7021451-1387-4CA6-816F-3879F97B5CBC}" type="slidenum">
               <a:rPr lang="en-US"/>
-              <a:t>13</a:t>
+              <a:t>17</a:t>
             </a:fld>
             <a:endParaRPr lang="en-US"/>
           </a:p>
@@ -954,7 +1337,7 @@
 </p:notes>
 </file>
 
-<file path=ppt/notesSlides/notesSlide14.xml><?xml version="1.0" encoding="utf-8"?>
+<file path=ppt/notesSlides/notesSlide18.xml><?xml version="1.0" encoding="utf-8"?>
 <p:notes xmlns:a="http://schemas.openxmlformats.org/drawingml/2006/main" xmlns:r="http://schemas.openxmlformats.org/officeDocument/2006/relationships" xmlns:p="http://schemas.openxmlformats.org/presentationml/2006/main">
   <p:cSld>
     <p:spTree>
@@ -1000,7 +1383,7 @@
           <a:p>
             <a:r>
               <a:rPr lang="en-US" dirty="0"/>
-              <a:t>A11 · The stage screen
+              <a:t>A15 · The stage screen
 The projector and the video call
 Bidding: photo, stats, bid, countdown, squads
 Players up for auction or the waiting list, 30 at a time
@@ -1028,7 +1411,7 @@
           <a:p>
             <a:fld id="{F7021451-1387-4CA6-816F-3879F97B5CBC}" type="slidenum">
               <a:rPr lang="en-US"/>
-              <a:t>14</a:t>
+              <a:t>18</a:t>
             </a:fld>
             <a:endParaRPr lang="en-US"/>
           </a:p>
@@ -1047,7 +1430,7 @@
 </p:notes>
 </file>
 
-<file path=ppt/notesSlides/notesSlide15.xml><?xml version="1.0" encoding="utf-8"?>
+<file path=ppt/notesSlides/notesSlide19.xml><?xml version="1.0" encoding="utf-8"?>
 <p:notes xmlns:a="http://schemas.openxmlformats.org/drawingml/2006/main" xmlns:r="http://schemas.openxmlformats.org/officeDocument/2006/relationships" xmlns:p="http://schemas.openxmlformats.org/presentationml/2006/main">
   <p:cSld>
     <p:spTree>
@@ -1093,7 +1476,198 @@
           <a:p>
             <a:r>
               <a:rPr lang="en-US" dirty="0"/>
-              <a:t>A12 · Offline backup
+              <a:t>A16 · SOLD, and commentary with punchlines
+Make the hall cheer
+SOLD: the stamp, a gavel (going, going, gone; one more knock for a record) and confetti in the buying team's colours
+Gavel and confetti
+On the stage, with phones joining in. Click the stage screen once so the browser allows sound. Switch off in the control room.
+Commentary humour
+Setup → Commentary humour: High (or Normal for just the facts). In English, Hinglish and Marathi: "Bidding war between ROY and THU. ₹90. This is getting personal." Jokes are about the auction and the money, never a person.</a:t>
+            </a:r>
+            <a:endParaRPr lang="en-US" dirty="0"/>
+          </a:p>
+        </p:txBody>
+      </p:sp>
+      <p:sp>
+        <p:nvSpPr>
+          <p:cNvPr id="4" name="Slide Number Placeholder 3"/>
+          <p:cNvSpPr>
+            <a:spLocks noGrp="1"/>
+          </p:cNvSpPr>
+          <p:nvPr>
+            <p:ph type="sldNum" sz="quarter" idx="10"/>
+          </p:nvPr>
+        </p:nvSpPr>
+        <p:spPr/>
+        <p:txBody>
+          <a:bodyPr/>
+          <a:lstStyle/>
+          <a:p>
+            <a:fld id="{F7021451-1387-4CA6-816F-3879F97B5CBC}" type="slidenum">
+              <a:rPr lang="en-US"/>
+              <a:t>19</a:t>
+            </a:fld>
+            <a:endParaRPr lang="en-US"/>
+          </a:p>
+        </p:txBody>
+      </p:sp>
+    </p:spTree>
+    <p:extLst>
+      <p:ext uri="{BB962C8B-B14F-4D97-AF65-F5344CB8AC3E}">
+        <p14:creationId xmlns:p14="http://schemas.microsoft.com/office/powerpoint/2010/main" val="1024086991"/>
+      </p:ext>
+    </p:extLst>
+  </p:cSld>
+  <p:clrMapOvr>
+    <a:masterClrMapping/>
+  </p:clrMapOvr>
+</p:notes>
+</file>
+
+<file path=ppt/notesSlides/notesSlide2.xml><?xml version="1.0" encoding="utf-8"?>
+<p:notes xmlns:a="http://schemas.openxmlformats.org/drawingml/2006/main" xmlns:r="http://schemas.openxmlformats.org/officeDocument/2006/relationships" xmlns:p="http://schemas.openxmlformats.org/presentationml/2006/main">
+  <p:cSld>
+    <p:spTree>
+      <p:nvGrpSpPr>
+        <p:cNvPr id="1" name=""/>
+        <p:cNvGrpSpPr/>
+        <p:nvPr/>
+      </p:nvGrpSpPr>
+      <p:grpSpPr>
+        <a:xfrm>
+          <a:off x="0" y="0"/>
+          <a:ext cx="0" cy="0"/>
+          <a:chOff x="0" y="0"/>
+          <a:chExt cx="0" cy="0"/>
+        </a:xfrm>
+      </p:grpSpPr>
+      <p:sp>
+        <p:nvSpPr>
+          <p:cNvPr id="2" name="Slide Image Placeholder 1"/>
+          <p:cNvSpPr>
+            <a:spLocks noGrp="1" noRot="1" noChangeAspect="1"/>
+          </p:cNvSpPr>
+          <p:nvPr>
+            <p:ph type="sldImg"/>
+          </p:nvPr>
+        </p:nvSpPr>
+        <p:spPr/>
+      </p:sp>
+      <p:sp>
+        <p:nvSpPr>
+          <p:cNvPr id="3" name="Notes Placeholder 2"/>
+          <p:cNvSpPr>
+            <a:spLocks noGrp="1"/>
+          </p:cNvSpPr>
+          <p:nvPr>
+            <p:ph type="body" idx="1"/>
+          </p:nvPr>
+        </p:nvSpPr>
+        <p:spPr/>
+        <p:txBody>
+          <a:bodyPr/>
+          <a:lstStyle/>
+          <a:p>
+            <a:r>
+              <a:rPr lang="en-US" dirty="0"/>
+              <a:t>Who does what
+One auction, a screen for every role
+Role · How they get in · What they do
+Admin (organiser) · Creates the auction (Google sign-in keeps it on your other devices) · Setup, teams, players, sharing, control room, results. Part A
+Co-admin · Admin code · Runs the control room on a second laptop
+Captain · Own team code · Bids on the phone, private workbook and budget plan. Part B
+Vice-captain · Own code, if allowed · Same as the captain, when the tournament lets both bid
+Members, audience · Auction code or link · Follow live: player, bids, squads, commentary, player profiles
+Stage screen · Stage link · Projector in the hall, or shared on Zoom / Meet
+Signing in with Google never makes anyone an admin of your auction: only its creator and people you give the admin code. Part C is the auction-day checklist.</a:t>
+            </a:r>
+            <a:endParaRPr lang="en-US" dirty="0"/>
+          </a:p>
+        </p:txBody>
+      </p:sp>
+      <p:sp>
+        <p:nvSpPr>
+          <p:cNvPr id="4" name="Slide Number Placeholder 3"/>
+          <p:cNvSpPr>
+            <a:spLocks noGrp="1"/>
+          </p:cNvSpPr>
+          <p:nvPr>
+            <p:ph type="sldNum" sz="quarter" idx="10"/>
+          </p:nvPr>
+        </p:nvSpPr>
+        <p:spPr/>
+        <p:txBody>
+          <a:bodyPr/>
+          <a:lstStyle/>
+          <a:p>
+            <a:fld id="{F7021451-1387-4CA6-816F-3879F97B5CBC}" type="slidenum">
+              <a:rPr lang="en-US"/>
+              <a:t>2</a:t>
+            </a:fld>
+            <a:endParaRPr lang="en-US"/>
+          </a:p>
+        </p:txBody>
+      </p:sp>
+    </p:spTree>
+    <p:extLst>
+      <p:ext uri="{BB962C8B-B14F-4D97-AF65-F5344CB8AC3E}">
+        <p14:creationId xmlns:p14="http://schemas.microsoft.com/office/powerpoint/2010/main" val="1024086991"/>
+      </p:ext>
+    </p:extLst>
+  </p:cSld>
+  <p:clrMapOvr>
+    <a:masterClrMapping/>
+  </p:clrMapOvr>
+</p:notes>
+</file>
+
+<file path=ppt/notesSlides/notesSlide20.xml><?xml version="1.0" encoding="utf-8"?>
+<p:notes xmlns:a="http://schemas.openxmlformats.org/drawingml/2006/main" xmlns:r="http://schemas.openxmlformats.org/officeDocument/2006/relationships" xmlns:p="http://schemas.openxmlformats.org/presentationml/2006/main">
+  <p:cSld>
+    <p:spTree>
+      <p:nvGrpSpPr>
+        <p:cNvPr id="1" name=""/>
+        <p:cNvGrpSpPr/>
+        <p:nvPr/>
+      </p:nvGrpSpPr>
+      <p:grpSpPr>
+        <a:xfrm>
+          <a:off x="0" y="0"/>
+          <a:ext cx="0" cy="0"/>
+          <a:chOff x="0" y="0"/>
+          <a:chExt cx="0" cy="0"/>
+        </a:xfrm>
+      </p:grpSpPr>
+      <p:sp>
+        <p:nvSpPr>
+          <p:cNvPr id="2" name="Slide Image Placeholder 1"/>
+          <p:cNvSpPr>
+            <a:spLocks noGrp="1" noRot="1" noChangeAspect="1"/>
+          </p:cNvSpPr>
+          <p:nvPr>
+            <p:ph type="sldImg"/>
+          </p:nvPr>
+        </p:nvSpPr>
+        <p:spPr/>
+      </p:sp>
+      <p:sp>
+        <p:nvSpPr>
+          <p:cNvPr id="3" name="Notes Placeholder 2"/>
+          <p:cNvSpPr>
+            <a:spLocks noGrp="1"/>
+          </p:cNvSpPr>
+          <p:nvPr>
+            <p:ph type="body" idx="1"/>
+          </p:nvPr>
+        </p:nvSpPr>
+        <p:spPr/>
+        <p:txBody>
+          <a:bodyPr/>
+          <a:lstStyle/>
+          <a:p>
+            <a:r>
+              <a:rPr lang="en-US" dirty="0"/>
+              <a:t>A17 · Offline backup
 Slides and an Excel tracker, for manual mode
 Slides (PowerPoint)
 Players → Slides. Rules, bid steps, teams, a clickable players list with numbers, and one slide per player with a small base-price tag.
@@ -1124,7 +1698,7 @@
           <a:p>
             <a:fld id="{F7021451-1387-4CA6-816F-3879F97B5CBC}" type="slidenum">
               <a:rPr lang="en-US"/>
-              <a:t>15</a:t>
+              <a:t>20</a:t>
             </a:fld>
             <a:endParaRPr lang="en-US"/>
           </a:p>
@@ -1143,7 +1717,7 @@
 </p:notes>
 </file>
 
-<file path=ppt/notesSlides/notesSlide16.xml><?xml version="1.0" encoding="utf-8"?>
+<file path=ppt/notesSlides/notesSlide21.xml><?xml version="1.0" encoding="utf-8"?>
 <p:notes xmlns:a="http://schemas.openxmlformats.org/drawingml/2006/main" xmlns:r="http://schemas.openxmlformats.org/officeDocument/2006/relationships" xmlns:p="http://schemas.openxmlformats.org/presentationml/2006/main">
   <p:cSld>
     <p:spTree>
@@ -1189,7 +1763,103 @@
           <a:p>
             <a:r>
               <a:rPr lang="en-US" dirty="0"/>
-              <a:t>A13 · Unsold round and results
+              <a:t>A18 · If something goes wrong
+Nothing is lost, and the auction carries on
+Download offline pack
+Top of the admin console, the offline banner and every error message. The Excel tracker already filled in with every sale and unsold player (purses, squads, max bids carry on from the next row), plus a backup file with everything.
+Database offline
+A red banner says so. Your changes stay in that tab and are sent when it's back: don't close or reload it. Phones can't bid meanwhile: take paddle bids, or carry on in the tracker.
+AI limit or AI down
+Every screen switches to the built-in commentary at once and AI is tried again after 1, 5 or 15 minutes, or with Try AI now.
+Press Download offline pack every 10–15 sales so the laptop always has a recent copy.</a:t>
+            </a:r>
+            <a:endParaRPr lang="en-US" dirty="0"/>
+          </a:p>
+        </p:txBody>
+      </p:sp>
+      <p:sp>
+        <p:nvSpPr>
+          <p:cNvPr id="4" name="Slide Number Placeholder 3"/>
+          <p:cNvSpPr>
+            <a:spLocks noGrp="1"/>
+          </p:cNvSpPr>
+          <p:nvPr>
+            <p:ph type="sldNum" sz="quarter" idx="10"/>
+          </p:nvPr>
+        </p:nvSpPr>
+        <p:spPr/>
+        <p:txBody>
+          <a:bodyPr/>
+          <a:lstStyle/>
+          <a:p>
+            <a:fld id="{F7021451-1387-4CA6-816F-3879F97B5CBC}" type="slidenum">
+              <a:rPr lang="en-US"/>
+              <a:t>21</a:t>
+            </a:fld>
+            <a:endParaRPr lang="en-US"/>
+          </a:p>
+        </p:txBody>
+      </p:sp>
+    </p:spTree>
+    <p:extLst>
+      <p:ext uri="{BB962C8B-B14F-4D97-AF65-F5344CB8AC3E}">
+        <p14:creationId xmlns:p14="http://schemas.microsoft.com/office/powerpoint/2010/main" val="1024086991"/>
+      </p:ext>
+    </p:extLst>
+  </p:cSld>
+  <p:clrMapOvr>
+    <a:masterClrMapping/>
+  </p:clrMapOvr>
+</p:notes>
+</file>
+
+<file path=ppt/notesSlides/notesSlide22.xml><?xml version="1.0" encoding="utf-8"?>
+<p:notes xmlns:a="http://schemas.openxmlformats.org/drawingml/2006/main" xmlns:r="http://schemas.openxmlformats.org/officeDocument/2006/relationships" xmlns:p="http://schemas.openxmlformats.org/presentationml/2006/main">
+  <p:cSld>
+    <p:spTree>
+      <p:nvGrpSpPr>
+        <p:cNvPr id="1" name=""/>
+        <p:cNvGrpSpPr/>
+        <p:nvPr/>
+      </p:nvGrpSpPr>
+      <p:grpSpPr>
+        <a:xfrm>
+          <a:off x="0" y="0"/>
+          <a:ext cx="0" cy="0"/>
+          <a:chOff x="0" y="0"/>
+          <a:chExt cx="0" cy="0"/>
+        </a:xfrm>
+      </p:grpSpPr>
+      <p:sp>
+        <p:nvSpPr>
+          <p:cNvPr id="2" name="Slide Image Placeholder 1"/>
+          <p:cNvSpPr>
+            <a:spLocks noGrp="1" noRot="1" noChangeAspect="1"/>
+          </p:cNvSpPr>
+          <p:nvPr>
+            <p:ph type="sldImg"/>
+          </p:nvPr>
+        </p:nvSpPr>
+        <p:spPr/>
+      </p:sp>
+      <p:sp>
+        <p:nvSpPr>
+          <p:cNvPr id="3" name="Notes Placeholder 2"/>
+          <p:cNvSpPr>
+            <a:spLocks noGrp="1"/>
+          </p:cNvSpPr>
+          <p:nvPr>
+            <p:ph type="body" idx="1"/>
+          </p:nvPr>
+        </p:nvSpPr>
+        <p:spPr/>
+        <p:txBody>
+          <a:bodyPr/>
+          <a:lstStyle/>
+          <a:p>
+            <a:r>
+              <a:rPr lang="en-US" dirty="0"/>
+              <a:t>A19 · Unsold round and results
 Finish, publish, and plan next season
 Unsold players come back after everyone has been up once, in the order they first came up.
 Finish the auction: squads and prices go to the results page, online for good.
@@ -1217,7 +1887,7 @@
           <a:p>
             <a:fld id="{F7021451-1387-4CA6-816F-3879F97B5CBC}" type="slidenum">
               <a:rPr lang="en-US"/>
-              <a:t>16</a:t>
+              <a:t>22</a:t>
             </a:fld>
             <a:endParaRPr lang="en-US"/>
           </a:p>
@@ -1236,7 +1906,7 @@
 </p:notes>
 </file>
 
-<file path=ppt/notesSlides/notesSlide17.xml><?xml version="1.0" encoding="utf-8"?>
+<file path=ppt/notesSlides/notesSlide23.xml><?xml version="1.0" encoding="utf-8"?>
 <p:notes xmlns:a="http://schemas.openxmlformats.org/drawingml/2006/main" xmlns:r="http://schemas.openxmlformats.org/officeDocument/2006/relationships" xmlns:p="http://schemas.openxmlformats.org/presentationml/2006/main">
   <p:cSld>
     <p:spTree>
@@ -1307,7 +1977,7 @@
           <a:p>
             <a:fld id="{F7021451-1387-4CA6-816F-3879F97B5CBC}" type="slidenum">
               <a:rPr lang="en-US"/>
-              <a:t>17</a:t>
+              <a:t>23</a:t>
             </a:fld>
             <a:endParaRPr lang="en-US"/>
           </a:p>
@@ -1326,7 +1996,7 @@
 </p:notes>
 </file>
 
-<file path=ppt/notesSlides/notesSlide18.xml><?xml version="1.0" encoding="utf-8"?>
+<file path=ppt/notesSlides/notesSlide24.xml><?xml version="1.0" encoding="utf-8"?>
 <p:notes xmlns:a="http://schemas.openxmlformats.org/drawingml/2006/main" xmlns:r="http://schemas.openxmlformats.org/officeDocument/2006/relationships" xmlns:p="http://schemas.openxmlformats.org/presentationml/2006/main">
   <p:cSld>
     <p:spTree>
@@ -1401,7 +2071,7 @@
           <a:p>
             <a:fld id="{F7021451-1387-4CA6-816F-3879F97B5CBC}" type="slidenum">
               <a:rPr lang="en-US"/>
-              <a:t>18</a:t>
+              <a:t>24</a:t>
             </a:fld>
             <a:endParaRPr lang="en-US"/>
           </a:p>
@@ -1420,7 +2090,7 @@
 </p:notes>
 </file>
 
-<file path=ppt/notesSlides/notesSlide19.xml><?xml version="1.0" encoding="utf-8"?>
+<file path=ppt/notesSlides/notesSlide25.xml><?xml version="1.0" encoding="utf-8"?>
 <p:notes xmlns:a="http://schemas.openxmlformats.org/drawingml/2006/main" xmlns:r="http://schemas.openxmlformats.org/officeDocument/2006/relationships" xmlns:p="http://schemas.openxmlformats.org/presentationml/2006/main">
   <p:cSld>
     <p:spTree>
@@ -1495,7 +2165,7 @@
           <a:p>
             <a:fld id="{F7021451-1387-4CA6-816F-3879F97B5CBC}" type="slidenum">
               <a:rPr lang="en-US"/>
-              <a:t>19</a:t>
+              <a:t>25</a:t>
             </a:fld>
             <a:endParaRPr lang="en-US"/>
           </a:p>
@@ -1514,104 +2184,7 @@
 </p:notes>
 </file>
 
-<file path=ppt/notesSlides/notesSlide2.xml><?xml version="1.0" encoding="utf-8"?>
-<p:notes xmlns:a="http://schemas.openxmlformats.org/drawingml/2006/main" xmlns:r="http://schemas.openxmlformats.org/officeDocument/2006/relationships" xmlns:p="http://schemas.openxmlformats.org/presentationml/2006/main">
-  <p:cSld>
-    <p:spTree>
-      <p:nvGrpSpPr>
-        <p:cNvPr id="1" name=""/>
-        <p:cNvGrpSpPr/>
-        <p:nvPr/>
-      </p:nvGrpSpPr>
-      <p:grpSpPr>
-        <a:xfrm>
-          <a:off x="0" y="0"/>
-          <a:ext cx="0" cy="0"/>
-          <a:chOff x="0" y="0"/>
-          <a:chExt cx="0" cy="0"/>
-        </a:xfrm>
-      </p:grpSpPr>
-      <p:sp>
-        <p:nvSpPr>
-          <p:cNvPr id="2" name="Slide Image Placeholder 1"/>
-          <p:cNvSpPr>
-            <a:spLocks noGrp="1" noRot="1" noChangeAspect="1"/>
-          </p:cNvSpPr>
-          <p:nvPr>
-            <p:ph type="sldImg"/>
-          </p:nvPr>
-        </p:nvSpPr>
-        <p:spPr/>
-      </p:sp>
-      <p:sp>
-        <p:nvSpPr>
-          <p:cNvPr id="3" name="Notes Placeholder 2"/>
-          <p:cNvSpPr>
-            <a:spLocks noGrp="1"/>
-          </p:cNvSpPr>
-          <p:nvPr>
-            <p:ph type="body" idx="1"/>
-          </p:nvPr>
-        </p:nvSpPr>
-        <p:spPr/>
-        <p:txBody>
-          <a:bodyPr/>
-          <a:lstStyle/>
-          <a:p>
-            <a:r>
-              <a:rPr lang="en-US" dirty="0"/>
-              <a:t>Who does what
-One auction, a screen for every role
-Role · How they get in · What they do
-Admin (organiser) · Creates the auction · Setup, teams, players, sharing, control room, results. Part A
-Co-admin · Admin code · Runs the control room on a second laptop
-Captain · Own team code · Bids on the phone, private workbook and budget plan. Part B
-Vice-captain · Own code, if allowed · Same as the captain, when the tournament lets both bid
-Members, audience · Auction code or link · Follow live: player, bids, squads, commentary, player profiles
-Stage screen · Stage link · Projector in the hall, or shared on Zoom / Meet
-Part C is a one-page checklist for the auction day.</a:t>
-            </a:r>
-            <a:endParaRPr lang="en-US" dirty="0"/>
-          </a:p>
-        </p:txBody>
-      </p:sp>
-      <p:sp>
-        <p:nvSpPr>
-          <p:cNvPr id="4" name="Slide Number Placeholder 3"/>
-          <p:cNvSpPr>
-            <a:spLocks noGrp="1"/>
-          </p:cNvSpPr>
-          <p:nvPr>
-            <p:ph type="sldNum" sz="quarter" idx="10"/>
-          </p:nvPr>
-        </p:nvSpPr>
-        <p:spPr/>
-        <p:txBody>
-          <a:bodyPr/>
-          <a:lstStyle/>
-          <a:p>
-            <a:fld id="{F7021451-1387-4CA6-816F-3879F97B5CBC}" type="slidenum">
-              <a:rPr lang="en-US"/>
-              <a:t>2</a:t>
-            </a:fld>
-            <a:endParaRPr lang="en-US"/>
-          </a:p>
-        </p:txBody>
-      </p:sp>
-    </p:spTree>
-    <p:extLst>
-      <p:ext uri="{BB962C8B-B14F-4D97-AF65-F5344CB8AC3E}">
-        <p14:creationId xmlns:p14="http://schemas.microsoft.com/office/powerpoint/2010/main" val="1024086991"/>
-      </p:ext>
-    </p:extLst>
-  </p:cSld>
-  <p:clrMapOvr>
-    <a:masterClrMapping/>
-  </p:clrMapOvr>
-</p:notes>
-</file>
-
-<file path=ppt/notesSlides/notesSlide20.xml><?xml version="1.0" encoding="utf-8"?>
+<file path=ppt/notesSlides/notesSlide26.xml><?xml version="1.0" encoding="utf-8"?>
 <p:notes xmlns:a="http://schemas.openxmlformats.org/drawingml/2006/main" xmlns:r="http://schemas.openxmlformats.org/officeDocument/2006/relationships" xmlns:p="http://schemas.openxmlformats.org/presentationml/2006/main">
   <p:cSld>
     <p:spTree>
@@ -1687,7 +2260,7 @@
           <a:p>
             <a:fld id="{F7021451-1387-4CA6-816F-3879F97B5CBC}" type="slidenum">
               <a:rPr lang="en-US"/>
-              <a:t>20</a:t>
+              <a:t>26</a:t>
             </a:fld>
             <a:endParaRPr lang="en-US"/>
           </a:p>
@@ -1706,7 +2279,7 @@
 </p:notes>
 </file>
 
-<file path=ppt/notesSlides/notesSlide21.xml><?xml version="1.0" encoding="utf-8"?>
+<file path=ppt/notesSlides/notesSlide27.xml><?xml version="1.0" encoding="utf-8"?>
 <p:notes xmlns:a="http://schemas.openxmlformats.org/drawingml/2006/main" xmlns:r="http://schemas.openxmlformats.org/officeDocument/2006/relationships" xmlns:p="http://schemas.openxmlformats.org/presentationml/2006/main">
   <p:cSld>
     <p:spTree>
@@ -1780,7 +2353,7 @@
           <a:p>
             <a:fld id="{F7021451-1387-4CA6-816F-3879F97B5CBC}" type="slidenum">
               <a:rPr lang="en-US"/>
-              <a:t>21</a:t>
+              <a:t>27</a:t>
             </a:fld>
             <a:endParaRPr lang="en-US"/>
           </a:p>
@@ -1799,7 +2372,7 @@
 </p:notes>
 </file>
 
-<file path=ppt/notesSlides/notesSlide22.xml><?xml version="1.0" encoding="utf-8"?>
+<file path=ppt/notesSlides/notesSlide28.xml><?xml version="1.0" encoding="utf-8"?>
 <p:notes xmlns:a="http://schemas.openxmlformats.org/drawingml/2006/main" xmlns:r="http://schemas.openxmlformats.org/officeDocument/2006/relationships" xmlns:p="http://schemas.openxmlformats.org/presentationml/2006/main">
   <p:cSld>
     <p:spTree>
@@ -1874,7 +2447,7 @@
           <a:p>
             <a:fld id="{F7021451-1387-4CA6-816F-3879F97B5CBC}" type="slidenum">
               <a:rPr lang="en-US"/>
-              <a:t>22</a:t>
+              <a:t>28</a:t>
             </a:fld>
             <a:endParaRPr lang="en-US"/>
           </a:p>
@@ -1893,7 +2466,7 @@
 </p:notes>
 </file>
 
-<file path=ppt/notesSlides/notesSlide23.xml><?xml version="1.0" encoding="utf-8"?>
+<file path=ppt/notesSlides/notesSlide29.xml><?xml version="1.0" encoding="utf-8"?>
 <p:notes xmlns:a="http://schemas.openxmlformats.org/drawingml/2006/main" xmlns:r="http://schemas.openxmlformats.org/officeDocument/2006/relationships" xmlns:p="http://schemas.openxmlformats.org/presentationml/2006/main">
   <p:cSld>
     <p:spTree>
@@ -1967,7 +2540,7 @@
           <a:p>
             <a:fld id="{F7021451-1387-4CA6-816F-3879F97B5CBC}" type="slidenum">
               <a:rPr lang="en-US"/>
-              <a:t>23</a:t>
+              <a:t>29</a:t>
             </a:fld>
             <a:endParaRPr lang="en-US"/>
           </a:p>
@@ -1986,7 +2559,97 @@
 </p:notes>
 </file>
 
-<file path=ppt/notesSlides/notesSlide24.xml><?xml version="1.0" encoding="utf-8"?>
+<file path=ppt/notesSlides/notesSlide3.xml><?xml version="1.0" encoding="utf-8"?>
+<p:notes xmlns:a="http://schemas.openxmlformats.org/drawingml/2006/main" xmlns:r="http://schemas.openxmlformats.org/officeDocument/2006/relationships" xmlns:p="http://schemas.openxmlformats.org/presentationml/2006/main">
+  <p:cSld>
+    <p:spTree>
+      <p:nvGrpSpPr>
+        <p:cNvPr id="1" name=""/>
+        <p:cNvGrpSpPr/>
+        <p:nvPr/>
+      </p:nvGrpSpPr>
+      <p:grpSpPr>
+        <a:xfrm>
+          <a:off x="0" y="0"/>
+          <a:ext cx="0" cy="0"/>
+          <a:chOff x="0" y="0"/>
+          <a:chExt cx="0" cy="0"/>
+        </a:xfrm>
+      </p:grpSpPr>
+      <p:sp>
+        <p:nvSpPr>
+          <p:cNvPr id="2" name="Slide Image Placeholder 1"/>
+          <p:cNvSpPr>
+            <a:spLocks noGrp="1" noRot="1" noChangeAspect="1"/>
+          </p:cNvSpPr>
+          <p:nvPr>
+            <p:ph type="sldImg"/>
+          </p:nvPr>
+        </p:nvSpPr>
+        <p:spPr/>
+      </p:sp>
+      <p:sp>
+        <p:nvSpPr>
+          <p:cNvPr id="3" name="Notes Placeholder 2"/>
+          <p:cNvSpPr>
+            <a:spLocks noGrp="1"/>
+          </p:cNvSpPr>
+          <p:nvPr>
+            <p:ph type="body" idx="1"/>
+          </p:nvPr>
+        </p:nvSpPr>
+        <p:spPr/>
+        <p:txBody>
+          <a:bodyPr/>
+          <a:lstStyle/>
+          <a:p>
+            <a:r>
+              <a:rPr lang="en-US" dirty="0"/>
+              <a:t>Part A
+For organisers
+Create the auction, set the rules, add teams and players, share it, rehearse, run it, and publish the results.</a:t>
+            </a:r>
+            <a:endParaRPr lang="en-US" dirty="0"/>
+          </a:p>
+        </p:txBody>
+      </p:sp>
+      <p:sp>
+        <p:nvSpPr>
+          <p:cNvPr id="4" name="Slide Number Placeholder 3"/>
+          <p:cNvSpPr>
+            <a:spLocks noGrp="1"/>
+          </p:cNvSpPr>
+          <p:nvPr>
+            <p:ph type="sldNum" sz="quarter" idx="10"/>
+          </p:nvPr>
+        </p:nvSpPr>
+        <p:spPr/>
+        <p:txBody>
+          <a:bodyPr/>
+          <a:lstStyle/>
+          <a:p>
+            <a:fld id="{F7021451-1387-4CA6-816F-3879F97B5CBC}" type="slidenum">
+              <a:rPr lang="en-US"/>
+              <a:t>3</a:t>
+            </a:fld>
+            <a:endParaRPr lang="en-US"/>
+          </a:p>
+        </p:txBody>
+      </p:sp>
+    </p:spTree>
+    <p:extLst>
+      <p:ext uri="{BB962C8B-B14F-4D97-AF65-F5344CB8AC3E}">
+        <p14:creationId xmlns:p14="http://schemas.microsoft.com/office/powerpoint/2010/main" val="1024086991"/>
+      </p:ext>
+    </p:extLst>
+  </p:cSld>
+  <p:clrMapOvr>
+    <a:masterClrMapping/>
+  </p:clrMapOvr>
+</p:notes>
+</file>
+
+<file path=ppt/notesSlides/notesSlide30.xml><?xml version="1.0" encoding="utf-8"?>
 <p:notes xmlns:a="http://schemas.openxmlformats.org/drawingml/2006/main" xmlns:r="http://schemas.openxmlformats.org/officeDocument/2006/relationships" xmlns:p="http://schemas.openxmlformats.org/presentationml/2006/main">
   <p:cSld>
     <p:spTree>
@@ -2041,13 +2704,15 @@
 Mock auction run with the captains, then reset or deleted
 Captain codes sent privately; visibility set to Link or Listed
 Slides and Excel tracker downloaded as a backup
+QR posters printed and pinned up
 In the hall
 Laptop on power, control room open; co-admin on a second laptop
-Stage on the projector in full screen (F11); V for voice
+Stage in full screen (F11), clicked once for the gavel; V for voice
 Captains joined and their workbooks open
 Chit bowl ready if drawing by chit
 Stage link shared on Zoom / Meet for those at home
-If the internet fails: carry on with the slides and the tracker</a:t>
+Download offline pack every 10–15 sales
+If the internet fails: carry on with the offline pack</a:t>
             </a:r>
             <a:endParaRPr lang="en-US" dirty="0"/>
           </a:p>
@@ -2070,7 +2735,7 @@
           <a:p>
             <a:fld id="{F7021451-1387-4CA6-816F-3879F97B5CBC}" type="slidenum">
               <a:rPr lang="en-US"/>
-              <a:t>24</a:t>
+              <a:t>30</a:t>
             </a:fld>
             <a:endParaRPr lang="en-US"/>
           </a:p>
@@ -2089,7 +2754,7 @@
 </p:notes>
 </file>
 
-<file path=ppt/notesSlides/notesSlide25.xml><?xml version="1.0" encoding="utf-8"?>
+<file path=ppt/notesSlides/notesSlide31.xml><?xml version="1.0" encoding="utf-8"?>
 <p:notes xmlns:a="http://schemas.openxmlformats.org/drawingml/2006/main" xmlns:r="http://schemas.openxmlformats.org/officeDocument/2006/relationships" xmlns:p="http://schemas.openxmlformats.org/presentationml/2006/main">
   <p:cSld>
     <p:spTree>
@@ -2166,97 +2831,7 @@
           <a:p>
             <a:fld id="{F7021451-1387-4CA6-816F-3879F97B5CBC}" type="slidenum">
               <a:rPr lang="en-US"/>
-              <a:t>25</a:t>
-            </a:fld>
-            <a:endParaRPr lang="en-US"/>
-          </a:p>
-        </p:txBody>
-      </p:sp>
-    </p:spTree>
-    <p:extLst>
-      <p:ext uri="{BB962C8B-B14F-4D97-AF65-F5344CB8AC3E}">
-        <p14:creationId xmlns:p14="http://schemas.microsoft.com/office/powerpoint/2010/main" val="1024086991"/>
-      </p:ext>
-    </p:extLst>
-  </p:cSld>
-  <p:clrMapOvr>
-    <a:masterClrMapping/>
-  </p:clrMapOvr>
-</p:notes>
-</file>
-
-<file path=ppt/notesSlides/notesSlide3.xml><?xml version="1.0" encoding="utf-8"?>
-<p:notes xmlns:a="http://schemas.openxmlformats.org/drawingml/2006/main" xmlns:r="http://schemas.openxmlformats.org/officeDocument/2006/relationships" xmlns:p="http://schemas.openxmlformats.org/presentationml/2006/main">
-  <p:cSld>
-    <p:spTree>
-      <p:nvGrpSpPr>
-        <p:cNvPr id="1" name=""/>
-        <p:cNvGrpSpPr/>
-        <p:nvPr/>
-      </p:nvGrpSpPr>
-      <p:grpSpPr>
-        <a:xfrm>
-          <a:off x="0" y="0"/>
-          <a:ext cx="0" cy="0"/>
-          <a:chOff x="0" y="0"/>
-          <a:chExt cx="0" cy="0"/>
-        </a:xfrm>
-      </p:grpSpPr>
-      <p:sp>
-        <p:nvSpPr>
-          <p:cNvPr id="2" name="Slide Image Placeholder 1"/>
-          <p:cNvSpPr>
-            <a:spLocks noGrp="1" noRot="1" noChangeAspect="1"/>
-          </p:cNvSpPr>
-          <p:nvPr>
-            <p:ph type="sldImg"/>
-          </p:nvPr>
-        </p:nvSpPr>
-        <p:spPr/>
-      </p:sp>
-      <p:sp>
-        <p:nvSpPr>
-          <p:cNvPr id="3" name="Notes Placeholder 2"/>
-          <p:cNvSpPr>
-            <a:spLocks noGrp="1"/>
-          </p:cNvSpPr>
-          <p:nvPr>
-            <p:ph type="body" idx="1"/>
-          </p:nvPr>
-        </p:nvSpPr>
-        <p:spPr/>
-        <p:txBody>
-          <a:bodyPr/>
-          <a:lstStyle/>
-          <a:p>
-            <a:r>
-              <a:rPr lang="en-US" dirty="0"/>
-              <a:t>Part A
-For organisers
-Create the auction, set the rules, add teams and players, share it, rehearse, run it, and publish the results.</a:t>
-            </a:r>
-            <a:endParaRPr lang="en-US" dirty="0"/>
-          </a:p>
-        </p:txBody>
-      </p:sp>
-      <p:sp>
-        <p:nvSpPr>
-          <p:cNvPr id="4" name="Slide Number Placeholder 3"/>
-          <p:cNvSpPr>
-            <a:spLocks noGrp="1"/>
-          </p:cNvSpPr>
-          <p:nvPr>
-            <p:ph type="sldNum" sz="quarter" idx="10"/>
-          </p:nvPr>
-        </p:nvSpPr>
-        <p:spPr/>
-        <p:txBody>
-          <a:bodyPr/>
-          <a:lstStyle/>
-          <a:p>
-            <a:fld id="{F7021451-1387-4CA6-816F-3879F97B5CBC}" type="slidenum">
-              <a:rPr lang="en-US"/>
-              <a:t>3</a:t>
+              <a:t>31</a:t>
             </a:fld>
             <a:endParaRPr lang="en-US"/>
           </a:p>
@@ -2427,7 +3002,7 @@
 Open the site and fill in Create a new auction: tournament, season, venue and date.
 Choose Major (a fresh player list) or Mini (built from last season: keep some players, release the rest).
 Press Create. You are now the admin of this auction on this browser.
-It starts Private: nobody else can see it until you share it (A6).
+It starts Private: nobody else can see it until you share it (A9).
 Past auctions can be added as a record too: Add a past auction (record) on the home page.</a:t>
             </a:r>
             <a:endParaRPr lang="en-US" dirty="0"/>
@@ -2609,7 +3184,100 @@
           <a:p>
             <a:r>
               <a:rPr lang="en-US" dirty="0"/>
-              <a:t>A4 · Teams
+              <a:t>A4 · Past seasons
+Last season's table, top performers and every team's record
+Setup → Past seasons → Add a season's record: the record file of an earlier season.
+Add a results block (README) for the final table, knockouts, champion and top performers.
+Phones get a Past seasons tab; each team shows what it did before, even if its name was spelt differently.
+Control room → On the stage → Season record puts it on the projector.</a:t>
+            </a:r>
+            <a:endParaRPr lang="en-US" dirty="0"/>
+          </a:p>
+        </p:txBody>
+      </p:sp>
+      <p:sp>
+        <p:nvSpPr>
+          <p:cNvPr id="4" name="Slide Number Placeholder 3"/>
+          <p:cNvSpPr>
+            <a:spLocks noGrp="1"/>
+          </p:cNvSpPr>
+          <p:nvPr>
+            <p:ph type="sldNum" sz="quarter" idx="10"/>
+          </p:nvPr>
+        </p:nvSpPr>
+        <p:spPr/>
+        <p:txBody>
+          <a:bodyPr/>
+          <a:lstStyle/>
+          <a:p>
+            <a:fld id="{F7021451-1387-4CA6-816F-3879F97B5CBC}" type="slidenum">
+              <a:rPr lang="en-US"/>
+              <a:t>7</a:t>
+            </a:fld>
+            <a:endParaRPr lang="en-US"/>
+          </a:p>
+        </p:txBody>
+      </p:sp>
+    </p:spTree>
+    <p:extLst>
+      <p:ext uri="{BB962C8B-B14F-4D97-AF65-F5344CB8AC3E}">
+        <p14:creationId xmlns:p14="http://schemas.microsoft.com/office/powerpoint/2010/main" val="1024086991"/>
+      </p:ext>
+    </p:extLst>
+  </p:cSld>
+  <p:clrMapOvr>
+    <a:masterClrMapping/>
+  </p:clrMapOvr>
+</p:notes>
+</file>
+
+<file path=ppt/notesSlides/notesSlide8.xml><?xml version="1.0" encoding="utf-8"?>
+<p:notes xmlns:a="http://schemas.openxmlformats.org/drawingml/2006/main" xmlns:r="http://schemas.openxmlformats.org/officeDocument/2006/relationships" xmlns:p="http://schemas.openxmlformats.org/presentationml/2006/main">
+  <p:cSld>
+    <p:spTree>
+      <p:nvGrpSpPr>
+        <p:cNvPr id="1" name=""/>
+        <p:cNvGrpSpPr/>
+        <p:nvPr/>
+      </p:nvGrpSpPr>
+      <p:grpSpPr>
+        <a:xfrm>
+          <a:off x="0" y="0"/>
+          <a:ext cx="0" cy="0"/>
+          <a:chOff x="0" y="0"/>
+          <a:chExt cx="0" cy="0"/>
+        </a:xfrm>
+      </p:grpSpPr>
+      <p:sp>
+        <p:nvSpPr>
+          <p:cNvPr id="2" name="Slide Image Placeholder 1"/>
+          <p:cNvSpPr>
+            <a:spLocks noGrp="1" noRot="1" noChangeAspect="1"/>
+          </p:cNvSpPr>
+          <p:nvPr>
+            <p:ph type="sldImg"/>
+          </p:nvPr>
+        </p:nvSpPr>
+        <p:spPr/>
+      </p:sp>
+      <p:sp>
+        <p:nvSpPr>
+          <p:cNvPr id="3" name="Notes Placeholder 2"/>
+          <p:cNvSpPr>
+            <a:spLocks noGrp="1"/>
+          </p:cNvSpPr>
+          <p:nvPr>
+            <p:ph type="body" idx="1"/>
+          </p:nvPr>
+        </p:nvSpPr>
+        <p:spPr/>
+        <p:txBody>
+          <a:bodyPr/>
+          <a:lstStyle/>
+          <a:p>
+            <a:r>
+              <a:rPr lang="en-US" dirty="0"/>
+              <a:t>A5 · Teams
 Upload the teams with their captains
 Teams → Upload the teams CSV, or add teams by hand.
 Captain, vice-captain and owner are optional. Use the same spelling as in the players list, so they are matched.
@@ -2636,7 +3304,7 @@
           <a:p>
             <a:fld id="{F7021451-1387-4CA6-816F-3879F97B5CBC}" type="slidenum">
               <a:rPr lang="en-US"/>
-              <a:t>7</a:t>
+              <a:t>8</a:t>
             </a:fld>
             <a:endParaRPr lang="en-US"/>
           </a:p>
@@ -2655,100 +3323,6 @@
 </p:notes>
 </file>
 
-<file path=ppt/notesSlides/notesSlide8.xml><?xml version="1.0" encoding="utf-8"?>
-<p:notes xmlns:a="http://schemas.openxmlformats.org/drawingml/2006/main" xmlns:r="http://schemas.openxmlformats.org/officeDocument/2006/relationships" xmlns:p="http://schemas.openxmlformats.org/presentationml/2006/main">
-  <p:cSld>
-    <p:spTree>
-      <p:nvGrpSpPr>
-        <p:cNvPr id="1" name=""/>
-        <p:cNvGrpSpPr/>
-        <p:nvPr/>
-      </p:nvGrpSpPr>
-      <p:grpSpPr>
-        <a:xfrm>
-          <a:off x="0" y="0"/>
-          <a:ext cx="0" cy="0"/>
-          <a:chOff x="0" y="0"/>
-          <a:chExt cx="0" cy="0"/>
-        </a:xfrm>
-      </p:grpSpPr>
-      <p:sp>
-        <p:nvSpPr>
-          <p:cNvPr id="2" name="Slide Image Placeholder 1"/>
-          <p:cNvSpPr>
-            <a:spLocks noGrp="1" noRot="1" noChangeAspect="1"/>
-          </p:cNvSpPr>
-          <p:nvPr>
-            <p:ph type="sldImg"/>
-          </p:nvPr>
-        </p:nvSpPr>
-        <p:spPr/>
-      </p:sp>
-      <p:sp>
-        <p:nvSpPr>
-          <p:cNvPr id="3" name="Notes Placeholder 2"/>
-          <p:cNvSpPr>
-            <a:spLocks noGrp="1"/>
-          </p:cNvSpPr>
-          <p:nvPr>
-            <p:ph type="body" idx="1"/>
-          </p:nvPr>
-        </p:nvSpPr>
-        <p:spPr/>
-        <p:txBody>
-          <a:bodyPr/>
-          <a:lstStyle/>
-          <a:p>
-            <a:r>
-              <a:rPr lang="en-US" dirty="0"/>
-              <a:t>A5 · Players
-Upload, check, choose each player's list, then lock
-Players → Upload the players CSV. Fix anything flagged, or edit in the table.
-List column for each player: Auction, Waiting list or Registration cancelled. Works even after locking (except for the player up for bidding).
-Player photos: one at a time, or many at once named by player number or full name.
-Lock the list when it is final.
-Waiting-list players come in only if you move them to Auction. Cancelled players stay on record but are left out of the auction, lists and downloads.</a:t>
-            </a:r>
-            <a:endParaRPr lang="en-US" dirty="0"/>
-          </a:p>
-        </p:txBody>
-      </p:sp>
-      <p:sp>
-        <p:nvSpPr>
-          <p:cNvPr id="4" name="Slide Number Placeholder 3"/>
-          <p:cNvSpPr>
-            <a:spLocks noGrp="1"/>
-          </p:cNvSpPr>
-          <p:nvPr>
-            <p:ph type="sldNum" sz="quarter" idx="10"/>
-          </p:nvPr>
-        </p:nvSpPr>
-        <p:spPr/>
-        <p:txBody>
-          <a:bodyPr/>
-          <a:lstStyle/>
-          <a:p>
-            <a:fld id="{F7021451-1387-4CA6-816F-3879F97B5CBC}" type="slidenum">
-              <a:rPr lang="en-US"/>
-              <a:t>8</a:t>
-            </a:fld>
-            <a:endParaRPr lang="en-US"/>
-          </a:p>
-        </p:txBody>
-      </p:sp>
-    </p:spTree>
-    <p:extLst>
-      <p:ext uri="{BB962C8B-B14F-4D97-AF65-F5344CB8AC3E}">
-        <p14:creationId xmlns:p14="http://schemas.microsoft.com/office/powerpoint/2010/main" val="1024086991"/>
-      </p:ext>
-    </p:extLst>
-  </p:cSld>
-  <p:clrMapOvr>
-    <a:masterClrMapping/>
-  </p:clrMapOvr>
-</p:notes>
-</file>
-
 <file path=ppt/notesSlides/notesSlide9.xml><?xml version="1.0" encoding="utf-8"?>
 <p:notes xmlns:a="http://schemas.openxmlformats.org/drawingml/2006/main" xmlns:r="http://schemas.openxmlformats.org/officeDocument/2006/relationships" xmlns:p="http://schemas.openxmlformats.org/presentationml/2006/main">
   <p:cSld>
@@ -2795,15 +3369,11 @@
           <a:p>
             <a:r>
               <a:rPr lang="en-US" dirty="0"/>
-              <a:t>A6 · Access and sharing
-Private while you set up, then share it
-Who can see · Meaning
-Private · Only admins. Use it while setting up.
-Link or code · Anyone with the link, QR or auction code.
-Listed · Also shown on the home page.
-Send each captain (and vice-captain) their own code, privately.
-Admin code lets a co-admin run the control room on another laptop.
-Present on Zoom or Meet: open the stage link and share that tab.</a:t>
+              <a:t>A6 · Team banners
+A banner for every team, and its profile on the stage
+Teams → Team banners: upload one at a time, or many at once named by team code (RAI.jpg).
+Phones show the banner above the team's squad.
+Control room → On the stage → A team's profile: banner, captain, vice-captain, squad so far and past seasons.</a:t>
             </a:r>
             <a:endParaRPr lang="en-US" dirty="0"/>
           </a:p>
@@ -4160,6 +4730,230 @@
 </p:sld>
 </file>
 
+<file path=ppt/slides/slide26.xml><?xml version="1.0" encoding="utf-8"?>
+<p:sld xmlns:a="http://schemas.openxmlformats.org/drawingml/2006/main" xmlns:r="http://schemas.openxmlformats.org/officeDocument/2006/relationships" xmlns:p="http://schemas.openxmlformats.org/presentationml/2006/main">
+  <p:cSld name="Slide 26">
+    <p:bg>
+      <p:bgPr>
+        <a:solidFill>
+          <a:srgbClr val="0D0F12"/>
+        </a:solidFill>
+      </p:bgPr>
+    </p:bg>
+    <p:spTree>
+      <p:nvGrpSpPr>
+        <p:cNvPr id="1" name=""/>
+        <p:cNvGrpSpPr/>
+        <p:nvPr/>
+      </p:nvGrpSpPr>
+      <p:grpSpPr>
+        <a:xfrm>
+          <a:off x="0" y="0"/>
+          <a:ext cx="0" cy="0"/>
+          <a:chOff x="0" y="0"/>
+          <a:chExt cx="0" cy="0"/>
+        </a:xfrm>
+      </p:grpSpPr>
+      <p:pic>
+        <p:nvPicPr>
+          <p:cNvPr id="2" name="Image 0" descr="/tmp/claude-0/-home-user-AuctionXI/7094d40b-077c-594e-8426-23b7e12fadb4/scratchpad/guide/out/s26.jpg">    </p:cNvPr>
+          <p:cNvPicPr>
+            <a:picLocks noChangeAspect="1"/>
+          </p:cNvPicPr>
+          <p:nvPr/>
+        </p:nvPicPr>
+        <p:blipFill>
+          <a:blip r:embed="rId1"/>
+          <a:stretch>
+            <a:fillRect/>
+          </a:stretch>
+        </p:blipFill>
+        <p:spPr>
+          <a:xfrm>
+            <a:off x="0" y="0"/>
+            <a:ext cx="12191695" cy="6858000"/>
+          </a:xfrm>
+          <a:prstGeom prst="rect">
+            <a:avLst/>
+          </a:prstGeom>
+        </p:spPr>
+      </p:pic>
+    </p:spTree>
+  </p:cSld>
+  <p:clrMapOvr>
+    <a:masterClrMapping/>
+  </p:clrMapOvr>
+</p:sld>
+</file>
+
+<file path=ppt/slides/slide27.xml><?xml version="1.0" encoding="utf-8"?>
+<p:sld xmlns:a="http://schemas.openxmlformats.org/drawingml/2006/main" xmlns:r="http://schemas.openxmlformats.org/officeDocument/2006/relationships" xmlns:p="http://schemas.openxmlformats.org/presentationml/2006/main">
+  <p:cSld name="Slide 27">
+    <p:bg>
+      <p:bgPr>
+        <a:solidFill>
+          <a:srgbClr val="0D0F12"/>
+        </a:solidFill>
+      </p:bgPr>
+    </p:bg>
+    <p:spTree>
+      <p:nvGrpSpPr>
+        <p:cNvPr id="1" name=""/>
+        <p:cNvGrpSpPr/>
+        <p:nvPr/>
+      </p:nvGrpSpPr>
+      <p:grpSpPr>
+        <a:xfrm>
+          <a:off x="0" y="0"/>
+          <a:ext cx="0" cy="0"/>
+          <a:chOff x="0" y="0"/>
+          <a:chExt cx="0" cy="0"/>
+        </a:xfrm>
+      </p:grpSpPr>
+      <p:pic>
+        <p:nvPicPr>
+          <p:cNvPr id="2" name="Image 0" descr="/tmp/claude-0/-home-user-AuctionXI/7094d40b-077c-594e-8426-23b7e12fadb4/scratchpad/guide/out/s27.jpg">    </p:cNvPr>
+          <p:cNvPicPr>
+            <a:picLocks noChangeAspect="1"/>
+          </p:cNvPicPr>
+          <p:nvPr/>
+        </p:nvPicPr>
+        <p:blipFill>
+          <a:blip r:embed="rId1"/>
+          <a:stretch>
+            <a:fillRect/>
+          </a:stretch>
+        </p:blipFill>
+        <p:spPr>
+          <a:xfrm>
+            <a:off x="0" y="0"/>
+            <a:ext cx="12191695" cy="6858000"/>
+          </a:xfrm>
+          <a:prstGeom prst="rect">
+            <a:avLst/>
+          </a:prstGeom>
+        </p:spPr>
+      </p:pic>
+    </p:spTree>
+  </p:cSld>
+  <p:clrMapOvr>
+    <a:masterClrMapping/>
+  </p:clrMapOvr>
+</p:sld>
+</file>
+
+<file path=ppt/slides/slide28.xml><?xml version="1.0" encoding="utf-8"?>
+<p:sld xmlns:a="http://schemas.openxmlformats.org/drawingml/2006/main" xmlns:r="http://schemas.openxmlformats.org/officeDocument/2006/relationships" xmlns:p="http://schemas.openxmlformats.org/presentationml/2006/main">
+  <p:cSld name="Slide 28">
+    <p:bg>
+      <p:bgPr>
+        <a:solidFill>
+          <a:srgbClr val="0D0F12"/>
+        </a:solidFill>
+      </p:bgPr>
+    </p:bg>
+    <p:spTree>
+      <p:nvGrpSpPr>
+        <p:cNvPr id="1" name=""/>
+        <p:cNvGrpSpPr/>
+        <p:nvPr/>
+      </p:nvGrpSpPr>
+      <p:grpSpPr>
+        <a:xfrm>
+          <a:off x="0" y="0"/>
+          <a:ext cx="0" cy="0"/>
+          <a:chOff x="0" y="0"/>
+          <a:chExt cx="0" cy="0"/>
+        </a:xfrm>
+      </p:grpSpPr>
+      <p:pic>
+        <p:nvPicPr>
+          <p:cNvPr id="2" name="Image 0" descr="/tmp/claude-0/-home-user-AuctionXI/7094d40b-077c-594e-8426-23b7e12fadb4/scratchpad/guide/out/s28.jpg">    </p:cNvPr>
+          <p:cNvPicPr>
+            <a:picLocks noChangeAspect="1"/>
+          </p:cNvPicPr>
+          <p:nvPr/>
+        </p:nvPicPr>
+        <p:blipFill>
+          <a:blip r:embed="rId1"/>
+          <a:stretch>
+            <a:fillRect/>
+          </a:stretch>
+        </p:blipFill>
+        <p:spPr>
+          <a:xfrm>
+            <a:off x="0" y="0"/>
+            <a:ext cx="12191695" cy="6858000"/>
+          </a:xfrm>
+          <a:prstGeom prst="rect">
+            <a:avLst/>
+          </a:prstGeom>
+        </p:spPr>
+      </p:pic>
+    </p:spTree>
+  </p:cSld>
+  <p:clrMapOvr>
+    <a:masterClrMapping/>
+  </p:clrMapOvr>
+</p:sld>
+</file>
+
+<file path=ppt/slides/slide29.xml><?xml version="1.0" encoding="utf-8"?>
+<p:sld xmlns:a="http://schemas.openxmlformats.org/drawingml/2006/main" xmlns:r="http://schemas.openxmlformats.org/officeDocument/2006/relationships" xmlns:p="http://schemas.openxmlformats.org/presentationml/2006/main">
+  <p:cSld name="Slide 29">
+    <p:bg>
+      <p:bgPr>
+        <a:solidFill>
+          <a:srgbClr val="0D0F12"/>
+        </a:solidFill>
+      </p:bgPr>
+    </p:bg>
+    <p:spTree>
+      <p:nvGrpSpPr>
+        <p:cNvPr id="1" name=""/>
+        <p:cNvGrpSpPr/>
+        <p:nvPr/>
+      </p:nvGrpSpPr>
+      <p:grpSpPr>
+        <a:xfrm>
+          <a:off x="0" y="0"/>
+          <a:ext cx="0" cy="0"/>
+          <a:chOff x="0" y="0"/>
+          <a:chExt cx="0" cy="0"/>
+        </a:xfrm>
+      </p:grpSpPr>
+      <p:pic>
+        <p:nvPicPr>
+          <p:cNvPr id="2" name="Image 0" descr="/tmp/claude-0/-home-user-AuctionXI/7094d40b-077c-594e-8426-23b7e12fadb4/scratchpad/guide/out/s29.jpg">    </p:cNvPr>
+          <p:cNvPicPr>
+            <a:picLocks noChangeAspect="1"/>
+          </p:cNvPicPr>
+          <p:nvPr/>
+        </p:nvPicPr>
+        <p:blipFill>
+          <a:blip r:embed="rId1"/>
+          <a:stretch>
+            <a:fillRect/>
+          </a:stretch>
+        </p:blipFill>
+        <p:spPr>
+          <a:xfrm>
+            <a:off x="0" y="0"/>
+            <a:ext cx="12191695" cy="6858000"/>
+          </a:xfrm>
+          <a:prstGeom prst="rect">
+            <a:avLst/>
+          </a:prstGeom>
+        </p:spPr>
+      </p:pic>
+    </p:spTree>
+  </p:cSld>
+  <p:clrMapOvr>
+    <a:masterClrMapping/>
+  </p:clrMapOvr>
+</p:sld>
+</file>
+
 <file path=ppt/slides/slide3.xml><?xml version="1.0" encoding="utf-8"?>
 <p:sld xmlns:a="http://schemas.openxmlformats.org/drawingml/2006/main" xmlns:r="http://schemas.openxmlformats.org/officeDocument/2006/relationships" xmlns:p="http://schemas.openxmlformats.org/presentationml/2006/main">
   <p:cSld name="Slide 3">
@@ -4187,6 +4981,118 @@
       <p:pic>
         <p:nvPicPr>
           <p:cNvPr id="2" name="Image 0" descr="/tmp/claude-0/-home-user-AuctionXI/7094d40b-077c-594e-8426-23b7e12fadb4/scratchpad/guide/out/s03.jpg">    </p:cNvPr>
+          <p:cNvPicPr>
+            <a:picLocks noChangeAspect="1"/>
+          </p:cNvPicPr>
+          <p:nvPr/>
+        </p:nvPicPr>
+        <p:blipFill>
+          <a:blip r:embed="rId1"/>
+          <a:stretch>
+            <a:fillRect/>
+          </a:stretch>
+        </p:blipFill>
+        <p:spPr>
+          <a:xfrm>
+            <a:off x="0" y="0"/>
+            <a:ext cx="12191695" cy="6858000"/>
+          </a:xfrm>
+          <a:prstGeom prst="rect">
+            <a:avLst/>
+          </a:prstGeom>
+        </p:spPr>
+      </p:pic>
+    </p:spTree>
+  </p:cSld>
+  <p:clrMapOvr>
+    <a:masterClrMapping/>
+  </p:clrMapOvr>
+</p:sld>
+</file>
+
+<file path=ppt/slides/slide30.xml><?xml version="1.0" encoding="utf-8"?>
+<p:sld xmlns:a="http://schemas.openxmlformats.org/drawingml/2006/main" xmlns:r="http://schemas.openxmlformats.org/officeDocument/2006/relationships" xmlns:p="http://schemas.openxmlformats.org/presentationml/2006/main">
+  <p:cSld name="Slide 30">
+    <p:bg>
+      <p:bgPr>
+        <a:solidFill>
+          <a:srgbClr val="0D0F12"/>
+        </a:solidFill>
+      </p:bgPr>
+    </p:bg>
+    <p:spTree>
+      <p:nvGrpSpPr>
+        <p:cNvPr id="1" name=""/>
+        <p:cNvGrpSpPr/>
+        <p:nvPr/>
+      </p:nvGrpSpPr>
+      <p:grpSpPr>
+        <a:xfrm>
+          <a:off x="0" y="0"/>
+          <a:ext cx="0" cy="0"/>
+          <a:chOff x="0" y="0"/>
+          <a:chExt cx="0" cy="0"/>
+        </a:xfrm>
+      </p:grpSpPr>
+      <p:pic>
+        <p:nvPicPr>
+          <p:cNvPr id="2" name="Image 0" descr="/tmp/claude-0/-home-user-AuctionXI/7094d40b-077c-594e-8426-23b7e12fadb4/scratchpad/guide/out/s30.jpg">    </p:cNvPr>
+          <p:cNvPicPr>
+            <a:picLocks noChangeAspect="1"/>
+          </p:cNvPicPr>
+          <p:nvPr/>
+        </p:nvPicPr>
+        <p:blipFill>
+          <a:blip r:embed="rId1"/>
+          <a:stretch>
+            <a:fillRect/>
+          </a:stretch>
+        </p:blipFill>
+        <p:spPr>
+          <a:xfrm>
+            <a:off x="0" y="0"/>
+            <a:ext cx="12191695" cy="6858000"/>
+          </a:xfrm>
+          <a:prstGeom prst="rect">
+            <a:avLst/>
+          </a:prstGeom>
+        </p:spPr>
+      </p:pic>
+    </p:spTree>
+  </p:cSld>
+  <p:clrMapOvr>
+    <a:masterClrMapping/>
+  </p:clrMapOvr>
+</p:sld>
+</file>
+
+<file path=ppt/slides/slide31.xml><?xml version="1.0" encoding="utf-8"?>
+<p:sld xmlns:a="http://schemas.openxmlformats.org/drawingml/2006/main" xmlns:r="http://schemas.openxmlformats.org/officeDocument/2006/relationships" xmlns:p="http://schemas.openxmlformats.org/presentationml/2006/main">
+  <p:cSld name="Slide 31">
+    <p:bg>
+      <p:bgPr>
+        <a:solidFill>
+          <a:srgbClr val="0D0F12"/>
+        </a:solidFill>
+      </p:bgPr>
+    </p:bg>
+    <p:spTree>
+      <p:nvGrpSpPr>
+        <p:cNvPr id="1" name=""/>
+        <p:cNvGrpSpPr/>
+        <p:nvPr/>
+      </p:nvGrpSpPr>
+      <p:grpSpPr>
+        <a:xfrm>
+          <a:off x="0" y="0"/>
+          <a:ext cx="0" cy="0"/>
+          <a:chOff x="0" y="0"/>
+          <a:chExt cx="0" cy="0"/>
+        </a:xfrm>
+      </p:grpSpPr>
+      <p:pic>
+        <p:nvPicPr>
+          <p:cNvPr id="2" name="Image 0" descr="/tmp/claude-0/-home-user-AuctionXI/7094d40b-077c-594e-8426-23b7e12fadb4/scratchpad/guide/out/s31.jpg">    </p:cNvPr>
           <p:cNvPicPr>
             <a:picLocks noChangeAspect="1"/>
           </p:cNvPicPr>

</xml_diff>